<commit_message>
docs(hardware): IBM dashboard screenshots as evidence, linked from runbook, README and slide 3
Co-Authored-By: Claude Opus 5.5 <noreply@anthropic.com>
</commit_message>
<xml_diff>
--- a/docs/slides.pptx
+++ b/docs/slides.pptx
@@ -3758,24 +3758,86 @@
         </p:blipFill>
         <p:spPr>
           <a:xfrm>
-            <a:off x="457200" y="1600200"/>
-            <a:ext cx="7680960" cy="3655122"/>
+            <a:off x="365760" y="1554480"/>
+            <a:ext cx="5852160" cy="2784855"/>
           </a:xfrm>
           <a:prstGeom prst="rect">
             <a:avLst/>
           </a:prstGeom>
         </p:spPr>
       </p:pic>
-      <p:sp>
-        <p:nvSpPr>
-          <p:cNvPr id="5" name="TextBox 4"/>
+      <p:pic>
+        <p:nvPicPr>
+          <p:cNvPr id="5" name="Picture 4" descr="ibm_job_histogram.png"/>
+          <p:cNvPicPr>
+            <a:picLocks noChangeAspect="1"/>
+          </p:cNvPicPr>
+          <p:nvPr/>
+        </p:nvPicPr>
+        <p:blipFill>
+          <a:blip r:embed="rId3"/>
+          <a:stretch>
+            <a:fillRect/>
+          </a:stretch>
+        </p:blipFill>
+        <p:spPr>
+          <a:xfrm>
+            <a:off x="6355080" y="1600200"/>
+            <a:ext cx="5486400" cy="2372497"/>
+          </a:xfrm>
+          <a:prstGeom prst="rect">
+            <a:avLst/>
+          </a:prstGeom>
+        </p:spPr>
+      </p:pic>
+      <p:sp>
+        <p:nvSpPr>
+          <p:cNvPr id="6" name="TextBox 5"/>
           <p:cNvSpPr txBox="1"/>
           <p:nvPr/>
         </p:nvSpPr>
         <p:spPr>
           <a:xfrm>
-            <a:off x="8412480" y="1737360"/>
-            <a:ext cx="3566160" cy="3840480"/>
+            <a:off x="6355080" y="4023360"/>
+            <a:ext cx="5486400" cy="731520"/>
+          </a:xfrm>
+          <a:prstGeom prst="rect">
+            <a:avLst/>
+          </a:prstGeom>
+          <a:noFill/>
+        </p:spPr>
+        <p:txBody>
+          <a:bodyPr wrap="square">
+            <a:spAutoFit/>
+          </a:bodyPr>
+          <a:lstStyle/>
+          <a:p>
+            <a:pPr>
+              <a:spcAft>
+                <a:spcPts val="600"/>
+              </a:spcAft>
+              <a:defRPr sz="1400" b="0">
+                <a:solidFill>
+                  <a:srgbClr val="3B1F7A"/>
+                </a:solidFill>
+              </a:defRPr>
+            </a:pPr>
+            <a:r>
+              <a:t>Real ibm_kingston output — tallest bar 1001 = optimal basket (RELIANCE+ITC), second 1100 = runner-up</a:t>
+            </a:r>
+          </a:p>
+        </p:txBody>
+      </p:sp>
+      <p:sp>
+        <p:nvSpPr>
+          <p:cNvPr id="7" name="TextBox 6"/>
+          <p:cNvSpPr txBox="1"/>
+          <p:nvPr/>
+        </p:nvSpPr>
+        <p:spPr>
+          <a:xfrm>
+            <a:off x="457200" y="4754880"/>
+            <a:ext cx="7863840" cy="1828800"/>
           </a:xfrm>
           <a:prstGeom prst="rect">
             <a:avLst/>
@@ -3836,14 +3898,14 @@
       </p:sp>
       <p:sp>
         <p:nvSpPr>
-          <p:cNvPr id="6" name="TextBox 5"/>
+          <p:cNvPr id="8" name="TextBox 7"/>
           <p:cNvSpPr txBox="1"/>
           <p:nvPr/>
         </p:nvSpPr>
         <p:spPr>
           <a:xfrm>
-            <a:off x="8412480" y="5486400"/>
-            <a:ext cx="3566160" cy="1097280"/>
+            <a:off x="8503920" y="5669280"/>
+            <a:ext cx="3474720" cy="914400"/>
           </a:xfrm>
           <a:prstGeom prst="rect">
             <a:avLst/>

</xml_diff>

<commit_message>
docs(slides): speaker notes, >=20pt text, final callouts, repo QR code
Co-Authored-By: Claude Opus 5.5 <noreply@anthropic.com>
</commit_message>
<xml_diff>
--- a/docs/slides.pptx
+++ b/docs/slides.pptx
@@ -6,8 +6,8 @@
   </p:sldMasterIdLst>
   <p:sldIdLst>
     <p:sldId id="256" r:id="rId7"/>
-    <p:sldId id="257" r:id="rId8"/>
-    <p:sldId id="258" r:id="rId9"/>
+    <p:sldId id="257" r:id="rId9"/>
+    <p:sldId id="258" r:id="rId10"/>
   </p:sldIdLst>
   <p:sldSz cx="12191695" cy="6858000" type="screen4x3"/>
   <p:notesSz cx="6858000" cy="9144000"/>
@@ -107,6 +107,566 @@
     </a:lvl9pPr>
   </p:defaultTextStyle>
 </p:presentation>
+</file>
+
+<file path=ppt/notesMasters/notesMaster1.xml><?xml version="1.0" encoding="utf-8"?>
+<p:notesMaster xmlns:a="http://schemas.openxmlformats.org/drawingml/2006/main" xmlns:p="http://schemas.openxmlformats.org/presentationml/2006/main" xmlns:r="http://schemas.openxmlformats.org/officeDocument/2006/relationships">
+  <p:cSld>
+    <p:bg>
+      <p:bgRef idx="1001">
+        <a:schemeClr val="bg1"/>
+      </p:bgRef>
+    </p:bg>
+    <p:spTree>
+      <p:nvGrpSpPr>
+        <p:cNvPr id="1" name=""/>
+        <p:cNvGrpSpPr/>
+        <p:nvPr/>
+      </p:nvGrpSpPr>
+      <p:grpSpPr>
+        <a:xfrm>
+          <a:off x="0" y="0"/>
+          <a:ext cx="0" cy="0"/>
+          <a:chOff x="0" y="0"/>
+          <a:chExt cx="0" cy="0"/>
+        </a:xfrm>
+      </p:grpSpPr>
+      <p:sp>
+        <p:nvSpPr>
+          <p:cNvPr id="2" name="Header Placeholder 1"/>
+          <p:cNvSpPr>
+            <a:spLocks noGrp="1"/>
+          </p:cNvSpPr>
+          <p:nvPr>
+            <p:ph type="hdr" sz="quarter"/>
+          </p:nvPr>
+        </p:nvSpPr>
+        <p:spPr>
+          <a:xfrm>
+            <a:off x="0" y="0"/>
+            <a:ext cx="2971800" cy="457200"/>
+          </a:xfrm>
+          <a:prstGeom prst="rect">
+            <a:avLst/>
+          </a:prstGeom>
+        </p:spPr>
+        <p:txBody>
+          <a:bodyPr vert="horz" lIns="91440" tIns="45720" rIns="91440" bIns="45720" rtlCol="0"/>
+          <a:lstStyle>
+            <a:lvl1pPr algn="l">
+              <a:defRPr sz="1200"/>
+            </a:lvl1pPr>
+          </a:lstStyle>
+          <a:p>
+            <a:endParaRPr lang="en-US"/>
+          </a:p>
+        </p:txBody>
+      </p:sp>
+      <p:sp>
+        <p:nvSpPr>
+          <p:cNvPr id="3" name="Date Placeholder 2"/>
+          <p:cNvSpPr>
+            <a:spLocks noGrp="1"/>
+          </p:cNvSpPr>
+          <p:nvPr>
+            <p:ph type="dt" idx="1"/>
+          </p:nvPr>
+        </p:nvSpPr>
+        <p:spPr>
+          <a:xfrm>
+            <a:off x="3884613" y="0"/>
+            <a:ext cx="2971800" cy="457200"/>
+          </a:xfrm>
+          <a:prstGeom prst="rect">
+            <a:avLst/>
+          </a:prstGeom>
+        </p:spPr>
+        <p:txBody>
+          <a:bodyPr vert="horz" lIns="91440" tIns="45720" rIns="91440" bIns="45720" rtlCol="0"/>
+          <a:lstStyle>
+            <a:lvl1pPr algn="r">
+              <a:defRPr sz="1200"/>
+            </a:lvl1pPr>
+          </a:lstStyle>
+          <a:p>
+            <a:fld id="{0F89C1C7-3DCD-1040-A9CF-14679D8B5DDD}" type="datetimeFigureOut">
+              <a:rPr lang="en-US" smtClean="0"/>
+              <a:t>10/17/16</a:t>
+            </a:fld>
+            <a:endParaRPr lang="en-US"/>
+          </a:p>
+        </p:txBody>
+      </p:sp>
+      <p:sp>
+        <p:nvSpPr>
+          <p:cNvPr id="4" name="Slide Image Placeholder 3"/>
+          <p:cNvSpPr>
+            <a:spLocks noGrp="1" noRot="1" noChangeAspect="1"/>
+          </p:cNvSpPr>
+          <p:nvPr>
+            <p:ph type="sldImg" idx="2"/>
+          </p:nvPr>
+        </p:nvSpPr>
+        <p:spPr>
+          <a:xfrm>
+            <a:off x="1143000" y="685800"/>
+            <a:ext cx="4572000" cy="3429000"/>
+          </a:xfrm>
+          <a:prstGeom prst="rect">
+            <a:avLst/>
+          </a:prstGeom>
+          <a:noFill/>
+          <a:ln w="12700">
+            <a:solidFill>
+              <a:prstClr val="black"/>
+            </a:solidFill>
+          </a:ln>
+        </p:spPr>
+        <p:txBody>
+          <a:bodyPr vert="horz" lIns="91440" tIns="45720" rIns="91440" bIns="45720" rtlCol="0" anchor="ctr"/>
+          <a:lstStyle/>
+          <a:p>
+            <a:endParaRPr lang="en-US"/>
+          </a:p>
+        </p:txBody>
+      </p:sp>
+      <p:sp>
+        <p:nvSpPr>
+          <p:cNvPr id="5" name="Notes Placeholder 4"/>
+          <p:cNvSpPr>
+            <a:spLocks noGrp="1"/>
+          </p:cNvSpPr>
+          <p:nvPr>
+            <p:ph type="body" sz="quarter" idx="3"/>
+          </p:nvPr>
+        </p:nvSpPr>
+        <p:spPr>
+          <a:xfrm>
+            <a:off x="685800" y="4343400"/>
+            <a:ext cx="5486400" cy="4114800"/>
+          </a:xfrm>
+          <a:prstGeom prst="rect">
+            <a:avLst/>
+          </a:prstGeom>
+        </p:spPr>
+        <p:txBody>
+          <a:bodyPr vert="horz" lIns="91440" tIns="45720" rIns="91440" bIns="45720" rtlCol="0"/>
+          <a:lstStyle/>
+          <a:p>
+            <a:pPr lvl="0"/>
+            <a:r>
+              <a:rPr lang="en-US" smtClean="0"/>
+              <a:t>Click to edit Master text styles</a:t>
+            </a:r>
+          </a:p>
+          <a:p>
+            <a:pPr lvl="1"/>
+            <a:r>
+              <a:rPr lang="en-US" smtClean="0"/>
+              <a:t>Second level</a:t>
+            </a:r>
+          </a:p>
+          <a:p>
+            <a:pPr lvl="2"/>
+            <a:r>
+              <a:rPr lang="en-US" smtClean="0"/>
+              <a:t>Third level</a:t>
+            </a:r>
+          </a:p>
+          <a:p>
+            <a:pPr lvl="3"/>
+            <a:r>
+              <a:rPr lang="en-US" smtClean="0"/>
+              <a:t>Fourth level</a:t>
+            </a:r>
+          </a:p>
+          <a:p>
+            <a:pPr lvl="4"/>
+            <a:r>
+              <a:rPr lang="en-US" smtClean="0"/>
+              <a:t>Fifth level</a:t>
+            </a:r>
+            <a:endParaRPr lang="en-US"/>
+          </a:p>
+        </p:txBody>
+      </p:sp>
+      <p:sp>
+        <p:nvSpPr>
+          <p:cNvPr id="6" name="Footer Placeholder 5"/>
+          <p:cNvSpPr>
+            <a:spLocks noGrp="1"/>
+          </p:cNvSpPr>
+          <p:nvPr>
+            <p:ph type="ftr" sz="quarter" idx="4"/>
+          </p:nvPr>
+        </p:nvSpPr>
+        <p:spPr>
+          <a:xfrm>
+            <a:off x="0" y="8685213"/>
+            <a:ext cx="2971800" cy="457200"/>
+          </a:xfrm>
+          <a:prstGeom prst="rect">
+            <a:avLst/>
+          </a:prstGeom>
+        </p:spPr>
+        <p:txBody>
+          <a:bodyPr vert="horz" lIns="91440" tIns="45720" rIns="91440" bIns="45720" rtlCol="0" anchor="b"/>
+          <a:lstStyle>
+            <a:lvl1pPr algn="l">
+              <a:defRPr sz="1200"/>
+            </a:lvl1pPr>
+          </a:lstStyle>
+          <a:p>
+            <a:endParaRPr lang="en-US"/>
+          </a:p>
+        </p:txBody>
+      </p:sp>
+      <p:sp>
+        <p:nvSpPr>
+          <p:cNvPr id="7" name="Slide Number Placeholder 6"/>
+          <p:cNvSpPr>
+            <a:spLocks noGrp="1"/>
+          </p:cNvSpPr>
+          <p:nvPr>
+            <p:ph type="sldNum" sz="quarter" idx="5"/>
+          </p:nvPr>
+        </p:nvSpPr>
+        <p:spPr>
+          <a:xfrm>
+            <a:off x="3884613" y="8685213"/>
+            <a:ext cx="2971800" cy="457200"/>
+          </a:xfrm>
+          <a:prstGeom prst="rect">
+            <a:avLst/>
+          </a:prstGeom>
+        </p:spPr>
+        <p:txBody>
+          <a:bodyPr vert="horz" lIns="91440" tIns="45720" rIns="91440" bIns="45720" rtlCol="0" anchor="b"/>
+          <a:lstStyle>
+            <a:lvl1pPr algn="r">
+              <a:defRPr sz="1200"/>
+            </a:lvl1pPr>
+          </a:lstStyle>
+          <a:p>
+            <a:fld id="{BB5E49A5-4136-284D-997B-48E1D791AD67}" type="slidenum">
+              <a:rPr lang="en-US" smtClean="0"/>
+              <a:t>‹#›</a:t>
+            </a:fld>
+            <a:endParaRPr lang="en-US"/>
+          </a:p>
+        </p:txBody>
+      </p:sp>
+    </p:spTree>
+    <p:extLst>
+      <p:ext uri="{BB962C8B-B14F-4D97-AF65-F5344CB8AC3E}">
+        <p14:creationId xmlns:p14="http://schemas.microsoft.com/office/powerpoint/2010/main" val="2623252185"/>
+      </p:ext>
+    </p:extLst>
+  </p:cSld>
+  <p:clrMap bg1="lt1" tx1="dk1" bg2="lt2" tx2="dk2" accent1="accent1" accent2="accent2" accent3="accent3" accent4="accent4" accent5="accent5" accent6="accent6" hlink="hlink" folHlink="folHlink"/>
+  <p:notesStyle>
+    <a:lvl1pPr marL="0" algn="l" defTabSz="457200" rtl="0" eaLnBrk="1" latinLnBrk="0" hangingPunct="1">
+      <a:defRPr sz="1200" kern="1200">
+        <a:solidFill>
+          <a:schemeClr val="tx1"/>
+        </a:solidFill>
+        <a:latin typeface="+mn-lt"/>
+        <a:ea typeface="+mn-ea"/>
+        <a:cs typeface="+mn-cs"/>
+      </a:defRPr>
+    </a:lvl1pPr>
+    <a:lvl2pPr marL="457200" algn="l" defTabSz="457200" rtl="0" eaLnBrk="1" latinLnBrk="0" hangingPunct="1">
+      <a:defRPr sz="1200" kern="1200">
+        <a:solidFill>
+          <a:schemeClr val="tx1"/>
+        </a:solidFill>
+        <a:latin typeface="+mn-lt"/>
+        <a:ea typeface="+mn-ea"/>
+        <a:cs typeface="+mn-cs"/>
+      </a:defRPr>
+    </a:lvl2pPr>
+    <a:lvl3pPr marL="914400" algn="l" defTabSz="457200" rtl="0" eaLnBrk="1" latinLnBrk="0" hangingPunct="1">
+      <a:defRPr sz="1200" kern="1200">
+        <a:solidFill>
+          <a:schemeClr val="tx1"/>
+        </a:solidFill>
+        <a:latin typeface="+mn-lt"/>
+        <a:ea typeface="+mn-ea"/>
+        <a:cs typeface="+mn-cs"/>
+      </a:defRPr>
+    </a:lvl3pPr>
+    <a:lvl4pPr marL="1371600" algn="l" defTabSz="457200" rtl="0" eaLnBrk="1" latinLnBrk="0" hangingPunct="1">
+      <a:defRPr sz="1200" kern="1200">
+        <a:solidFill>
+          <a:schemeClr val="tx1"/>
+        </a:solidFill>
+        <a:latin typeface="+mn-lt"/>
+        <a:ea typeface="+mn-ea"/>
+        <a:cs typeface="+mn-cs"/>
+      </a:defRPr>
+    </a:lvl4pPr>
+    <a:lvl5pPr marL="1828800" algn="l" defTabSz="457200" rtl="0" eaLnBrk="1" latinLnBrk="0" hangingPunct="1">
+      <a:defRPr sz="1200" kern="1200">
+        <a:solidFill>
+          <a:schemeClr val="tx1"/>
+        </a:solidFill>
+        <a:latin typeface="+mn-lt"/>
+        <a:ea typeface="+mn-ea"/>
+        <a:cs typeface="+mn-cs"/>
+      </a:defRPr>
+    </a:lvl5pPr>
+    <a:lvl6pPr marL="2286000" algn="l" defTabSz="457200" rtl="0" eaLnBrk="1" latinLnBrk="0" hangingPunct="1">
+      <a:defRPr sz="1200" kern="1200">
+        <a:solidFill>
+          <a:schemeClr val="tx1"/>
+        </a:solidFill>
+        <a:latin typeface="+mn-lt"/>
+        <a:ea typeface="+mn-ea"/>
+        <a:cs typeface="+mn-cs"/>
+      </a:defRPr>
+    </a:lvl6pPr>
+    <a:lvl7pPr marL="2743200" algn="l" defTabSz="457200" rtl="0" eaLnBrk="1" latinLnBrk="0" hangingPunct="1">
+      <a:defRPr sz="1200" kern="1200">
+        <a:solidFill>
+          <a:schemeClr val="tx1"/>
+        </a:solidFill>
+        <a:latin typeface="+mn-lt"/>
+        <a:ea typeface="+mn-ea"/>
+        <a:cs typeface="+mn-cs"/>
+      </a:defRPr>
+    </a:lvl7pPr>
+    <a:lvl8pPr marL="3200400" algn="l" defTabSz="457200" rtl="0" eaLnBrk="1" latinLnBrk="0" hangingPunct="1">
+      <a:defRPr sz="1200" kern="1200">
+        <a:solidFill>
+          <a:schemeClr val="tx1"/>
+        </a:solidFill>
+        <a:latin typeface="+mn-lt"/>
+        <a:ea typeface="+mn-ea"/>
+        <a:cs typeface="+mn-cs"/>
+      </a:defRPr>
+    </a:lvl8pPr>
+    <a:lvl9pPr marL="3657600" algn="l" defTabSz="457200" rtl="0" eaLnBrk="1" latinLnBrk="0" hangingPunct="1">
+      <a:defRPr sz="1200" kern="1200">
+        <a:solidFill>
+          <a:schemeClr val="tx1"/>
+        </a:solidFill>
+        <a:latin typeface="+mn-lt"/>
+        <a:ea typeface="+mn-ea"/>
+        <a:cs typeface="+mn-cs"/>
+      </a:defRPr>
+    </a:lvl9pPr>
+  </p:notesStyle>
+</p:notesMaster>
+</file>
+
+<file path=ppt/notesSlides/notesSlide1.xml><?xml version="1.0" encoding="utf-8"?>
+<p:notes xmlns:a="http://schemas.openxmlformats.org/drawingml/2006/main" xmlns:p="http://schemas.openxmlformats.org/presentationml/2006/main" xmlns:r="http://schemas.openxmlformats.org/officeDocument/2006/relationships">
+  <p:cSld>
+    <p:spTree>
+      <p:nvGrpSpPr>
+        <p:cNvPr id="1" name=""/>
+        <p:cNvGrpSpPr/>
+        <p:nvPr/>
+      </p:nvGrpSpPr>
+      <p:grpSpPr>
+        <a:xfrm>
+          <a:off x="0" y="0"/>
+          <a:ext cx="0" cy="0"/>
+          <a:chOff x="0" y="0"/>
+          <a:chExt cx="0" cy="0"/>
+        </a:xfrm>
+      </p:grpSpPr>
+      <p:sp>
+        <p:nvSpPr>
+          <p:cNvPr id="2" name="Slide Image Placeholder 1"/>
+          <p:cNvSpPr>
+            <a:spLocks noGrp="1"/>
+          </p:cNvSpPr>
+          <p:nvPr>
+            <p:ph type="sldImg" idx="2"/>
+          </p:nvPr>
+        </p:nvSpPr>
+        <p:spPr/>
+      </p:sp>
+      <p:sp>
+        <p:nvSpPr>
+          <p:cNvPr id="3" name="Notes Placeholder 2"/>
+          <p:cNvSpPr>
+            <a:spLocks noGrp="1"/>
+          </p:cNvSpPr>
+          <p:nvPr>
+            <p:ph type="body" idx="3" sz="quarter"/>
+          </p:nvPr>
+        </p:nvSpPr>
+        <p:spPr/>
+        <p:txBody>
+          <a:bodyPr/>
+          <a:lstStyle/>
+          <a:p>
+            <a:r>
+              <a:t>Robo-advisors in India sell model baskets: a few stocks, equal weights, for a given risk profile. Choosing which k stocks go in is a combinatorial problem. Here I pick 3 of 6 NSE large caps, which is 20 possible baskets; each dot on this chart is one of them. We want return up and risk down, and the client's risk aversion q sets the trade-off. The blue star is the best basket for q = 0.5, and the orange diamond is a very close runner-up. At 20 baskets a laptop checks them all instantly, but the count explodes as C(n,k), so it is a natural test bed for quantum optimisation.</a:t>
+            </a:r>
+          </a:p>
+        </p:txBody>
+      </p:sp>
+      <p:sp>
+        <p:nvSpPr>
+          <p:cNvPr id="4" name="Slide Number Placeholder 3"/>
+          <p:cNvSpPr>
+            <a:spLocks noGrp="1"/>
+          </p:cNvSpPr>
+          <p:nvPr>
+            <p:ph type="sldNum" idx="5" sz="quarter"/>
+          </p:nvPr>
+        </p:nvSpPr>
+        <p:spPr/>
+      </p:sp>
+    </p:spTree>
+  </p:cSld>
+  <p:clrMapOvr>
+    <a:masterClrMapping/>
+  </p:clrMapOvr>
+</p:notes>
+</file>
+
+<file path=ppt/notesSlides/notesSlide2.xml><?xml version="1.0" encoding="utf-8"?>
+<p:notes xmlns:a="http://schemas.openxmlformats.org/drawingml/2006/main" xmlns:p="http://schemas.openxmlformats.org/presentationml/2006/main" xmlns:r="http://schemas.openxmlformats.org/officeDocument/2006/relationships">
+  <p:cSld>
+    <p:spTree>
+      <p:nvGrpSpPr>
+        <p:cNvPr id="1" name=""/>
+        <p:cNvGrpSpPr/>
+        <p:nvPr/>
+      </p:nvGrpSpPr>
+      <p:grpSpPr>
+        <a:xfrm>
+          <a:off x="0" y="0"/>
+          <a:ext cx="0" cy="0"/>
+          <a:chOff x="0" y="0"/>
+          <a:chExt cx="0" cy="0"/>
+        </a:xfrm>
+      </p:grpSpPr>
+      <p:sp>
+        <p:nvSpPr>
+          <p:cNvPr id="2" name="Slide Image Placeholder 1"/>
+          <p:cNvSpPr>
+            <a:spLocks noGrp="1"/>
+          </p:cNvSpPr>
+          <p:nvPr>
+            <p:ph type="sldImg" idx="2"/>
+          </p:nvPr>
+        </p:nvSpPr>
+        <p:spPr/>
+      </p:sp>
+      <p:sp>
+        <p:nvSpPr>
+          <p:cNvPr id="3" name="Notes Placeholder 2"/>
+          <p:cNvSpPr>
+            <a:spLocks noGrp="1"/>
+          </p:cNvSpPr>
+          <p:nvPr>
+            <p:ph type="body" idx="3" sz="quarter"/>
+          </p:nvPr>
+        </p:nvSpPr>
+        <p:spPr/>
+        <p:txBody>
+          <a:bodyPr/>
+          <a:lstStyle/>
+          <a:p>
+            <a:r>
+              <a:t>The textbook way to say 'exactly 3 stocks' is a penalty term in the cost. I tested it carefully: only 75% of its samples are valid baskets, and it finds the best one 4% of the time, the same as random guessing at 5%. So I moved the constraint into the circuit. A Dicke state starts in an equal mix of only the valid baskets, and an XY mixer swaps stocks in and out without changing the count. Every shot is a real portfolio. Over 24 test instances the best basket comes up 34% of the time, about the same as simulated annealing at 36%. Grey bars are classical baselines, blue is ours, orange is the penalty approach.</a:t>
+            </a:r>
+          </a:p>
+        </p:txBody>
+      </p:sp>
+      <p:sp>
+        <p:nvSpPr>
+          <p:cNvPr id="4" name="Slide Number Placeholder 3"/>
+          <p:cNvSpPr>
+            <a:spLocks noGrp="1"/>
+          </p:cNvSpPr>
+          <p:nvPr>
+            <p:ph type="sldNum" idx="5" sz="quarter"/>
+          </p:nvPr>
+        </p:nvSpPr>
+        <p:spPr/>
+      </p:sp>
+    </p:spTree>
+  </p:cSld>
+  <p:clrMapOvr>
+    <a:masterClrMapping/>
+  </p:clrMapOvr>
+</p:notes>
+</file>
+
+<file path=ppt/notesSlides/notesSlide3.xml><?xml version="1.0" encoding="utf-8"?>
+<p:notes xmlns:a="http://schemas.openxmlformats.org/drawingml/2006/main" xmlns:p="http://schemas.openxmlformats.org/presentationml/2006/main" xmlns:r="http://schemas.openxmlformats.org/officeDocument/2006/relationships">
+  <p:cSld>
+    <p:spTree>
+      <p:nvGrpSpPr>
+        <p:cNvPr id="1" name=""/>
+        <p:cNvGrpSpPr/>
+        <p:nvPr/>
+      </p:nvGrpSpPr>
+      <p:grpSpPr>
+        <a:xfrm>
+          <a:off x="0" y="0"/>
+          <a:ext cx="0" cy="0"/>
+          <a:chOff x="0" y="0"/>
+          <a:chExt cx="0" cy="0"/>
+        </a:xfrm>
+      </p:grpSpPr>
+      <p:sp>
+        <p:nvSpPr>
+          <p:cNvPr id="2" name="Slide Image Placeholder 1"/>
+          <p:cNvSpPr>
+            <a:spLocks noGrp="1"/>
+          </p:cNvSpPr>
+          <p:nvPr>
+            <p:ph type="sldImg" idx="2"/>
+          </p:nvPr>
+        </p:nvSpPr>
+        <p:spPr/>
+      </p:sp>
+      <p:sp>
+        <p:nvSpPr>
+          <p:cNvPr id="3" name="Notes Placeholder 2"/>
+          <p:cNvSpPr>
+            <a:spLocks noGrp="1"/>
+          </p:cNvSpPr>
+          <p:nvPr>
+            <p:ph type="body" idx="3" sz="quarter"/>
+          </p:nvPr>
+        </p:nvSpPr>
+        <p:spPr/>
+        <p:txBody>
+          <a:bodyPr/>
+          <a:lstStyle/>
+          <a:p>
+            <a:r>
+              <a:t>Then I ran the same circuit on IBM's ibm_kingston, with 4 stocks and 2 picked. On the left is the raw output from the IBM dashboard: the tallest bar is the optimal basket and the second is the runner-up. Noise lets some invalid baskets through, about 22% of shots. The ideal circuit can never produce them, so I simply throw them away. That is free error detection. The optimal basket goes from 51% to 65%, against 17% for a random guess. Honest limits: at this size a laptop solves it instantly, so I claim no quantum advantage. The point is that building business constraints into the circuit is what makes quantum optimisation work at all. Code and live demo are behind the QR codes.</a:t>
+            </a:r>
+          </a:p>
+        </p:txBody>
+      </p:sp>
+      <p:sp>
+        <p:nvSpPr>
+          <p:cNvPr id="4" name="Slide Number Placeholder 3"/>
+          <p:cNvSpPr>
+            <a:spLocks noGrp="1"/>
+          </p:cNvSpPr>
+          <p:nvPr>
+            <p:ph type="sldNum" idx="5" sz="quarter"/>
+          </p:nvPr>
+        </p:nvSpPr>
+        <p:spPr/>
+      </p:sp>
+    </p:spTree>
+  </p:cSld>
+  <p:clrMapOvr>
+    <a:masterClrMapping/>
+  </p:clrMapOvr>
+</p:notes>
 </file>
 
 <file path=ppt/slideLayouts/slideLayout1.xml><?xml version="1.0" encoding="utf-8"?>
@@ -3136,7 +3696,7 @@
         </p:nvSpPr>
         <p:spPr>
           <a:xfrm>
-            <a:off x="457200" y="1005840"/>
+            <a:off x="457200" y="960120"/>
             <a:ext cx="11247120" cy="457200"/>
           </a:xfrm>
           <a:prstGeom prst="rect">
@@ -3154,7 +3714,7 @@
               <a:spcAft>
                 <a:spcPts val="600"/>
               </a:spcAft>
-              <a:defRPr sz="1800" b="0">
+              <a:defRPr sz="2000" b="0">
                 <a:solidFill>
                   <a:srgbClr val="444444"/>
                 </a:solidFill>
@@ -3322,8 +3882,8 @@
         </p:nvSpPr>
         <p:spPr>
           <a:xfrm>
-            <a:off x="457200" y="1143000"/>
-            <a:ext cx="5486400" cy="1463040"/>
+            <a:off x="457200" y="1097280"/>
+            <a:ext cx="5486400" cy="1417320"/>
           </a:xfrm>
           <a:prstGeom prst="rect">
             <a:avLst/>
@@ -3367,7 +3927,7 @@
         </p:nvSpPr>
         <p:spPr>
           <a:xfrm>
-            <a:off x="640080" y="1234440"/>
+            <a:off x="640080" y="1170432"/>
             <a:ext cx="5120640" cy="457200"/>
           </a:xfrm>
           <a:prstGeom prst="rect">
@@ -3385,7 +3945,7 @@
               <a:spcAft>
                 <a:spcPts val="600"/>
               </a:spcAft>
-              <a:defRPr sz="2200" b="1">
+              <a:defRPr sz="2400" b="1">
                 <a:solidFill>
                   <a:srgbClr val="E86738"/>
                 </a:solidFill>
@@ -3405,7 +3965,7 @@
         </p:nvSpPr>
         <p:spPr>
           <a:xfrm>
-            <a:off x="640080" y="1737360"/>
+            <a:off x="640080" y="1645919"/>
             <a:ext cx="5120640" cy="822960"/>
           </a:xfrm>
           <a:prstGeom prst="rect">
@@ -3423,14 +3983,14 @@
               <a:spcAft>
                 <a:spcPts val="600"/>
               </a:spcAft>
-              <a:defRPr sz="1700" b="0">
+              <a:defRPr sz="2000" b="0">
                 <a:solidFill>
                   <a:srgbClr val="444444"/>
                 </a:solidFill>
               </a:defRPr>
             </a:pPr>
             <a:r>
-              <a:t>Searches all 64 bit strings, 44 of them invalid.</a:t>
+              <a:t>Searches all 64 bit strings, 44 invalid</a:t>
             </a:r>
           </a:p>
           <a:p>
@@ -3438,7 +3998,7 @@
               <a:spcAft>
                 <a:spcPts val="600"/>
               </a:spcAft>
-              <a:defRPr sz="1700" b="0">
+              <a:defRPr sz="2000" b="0">
                 <a:solidFill>
                   <a:srgbClr val="444444"/>
                 </a:solidFill>
@@ -3458,8 +4018,8 @@
         </p:nvSpPr>
         <p:spPr>
           <a:xfrm>
-            <a:off x="6263640" y="1143000"/>
-            <a:ext cx="5486400" cy="1463040"/>
+            <a:off x="6263640" y="1097280"/>
+            <a:ext cx="5486400" cy="1417320"/>
           </a:xfrm>
           <a:prstGeom prst="rect">
             <a:avLst/>
@@ -3503,7 +4063,7 @@
         </p:nvSpPr>
         <p:spPr>
           <a:xfrm>
-            <a:off x="6446520" y="1234440"/>
+            <a:off x="6446520" y="1170432"/>
             <a:ext cx="5120640" cy="457200"/>
           </a:xfrm>
           <a:prstGeom prst="rect">
@@ -3521,7 +4081,7 @@
               <a:spcAft>
                 <a:spcPts val="600"/>
               </a:spcAft>
-              <a:defRPr sz="2200" b="1">
+              <a:defRPr sz="2400" b="1">
                 <a:solidFill>
                   <a:srgbClr val="2A78D6"/>
                 </a:solidFill>
@@ -3541,7 +4101,7 @@
         </p:nvSpPr>
         <p:spPr>
           <a:xfrm>
-            <a:off x="6446520" y="1737360"/>
+            <a:off x="6446520" y="1645919"/>
             <a:ext cx="5120640" cy="822960"/>
           </a:xfrm>
           <a:prstGeom prst="rect">
@@ -3559,14 +4119,14 @@
               <a:spcAft>
                 <a:spcPts val="600"/>
               </a:spcAft>
-              <a:defRPr sz="1700" b="0">
+              <a:defRPr sz="2000" b="0">
                 <a:solidFill>
                   <a:srgbClr val="444444"/>
                 </a:solidFill>
               </a:defRPr>
             </a:pPr>
             <a:r>
-              <a:t>Only ever visits the 20 valid baskets.</a:t>
+              <a:t>Only ever visits the 20 valid baskets</a:t>
             </a:r>
           </a:p>
           <a:p>
@@ -3574,7 +4134,7 @@
               <a:spcAft>
                 <a:spcPts val="600"/>
               </a:spcAft>
-              <a:defRPr sz="1700" b="0">
+              <a:defRPr sz="2000" b="0">
                 <a:solidFill>
                   <a:srgbClr val="444444"/>
                 </a:solidFill>
@@ -3602,8 +4162,8 @@
         </p:blipFill>
         <p:spPr>
           <a:xfrm>
-            <a:off x="457200" y="2788920"/>
-            <a:ext cx="11247120" cy="3744830"/>
+            <a:off x="1234440" y="2606040"/>
+            <a:ext cx="9692640" cy="3227252"/>
           </a:xfrm>
           <a:prstGeom prst="rect">
             <a:avLst/>
@@ -3618,8 +4178,8 @@
         </p:nvSpPr>
         <p:spPr>
           <a:xfrm>
-            <a:off x="457200" y="6400800"/>
-            <a:ext cx="11247120" cy="411480"/>
+            <a:off x="457200" y="5852160"/>
+            <a:ext cx="11247120" cy="548640"/>
           </a:xfrm>
           <a:prstGeom prst="rect">
             <a:avLst/>
@@ -3636,14 +4196,29 @@
               <a:spcAft>
                 <a:spcPts val="600"/>
               </a:spcAft>
-              <a:defRPr sz="1800" b="1">
+              <a:defRPr sz="2000" b="1">
                 <a:solidFill>
                   <a:srgbClr val="3B1F7A"/>
                 </a:solidFill>
               </a:defRPr>
             </a:pPr>
             <a:r>
-              <a:t>~7× chance (P(optimal) 0.34 vs 0.05, 24 instances) · 100% valid · penalty-QAOA = chance (0.04, 75% valid)</a:t>
+              <a:t>100% valid baskets · P(optimal) 0.34 vs 0.05 random</a:t>
+            </a:r>
+          </a:p>
+          <a:p>
+            <a:pPr>
+              <a:spcAft>
+                <a:spcPts val="600"/>
+              </a:spcAft>
+              <a:defRPr sz="2000" b="1">
+                <a:solidFill>
+                  <a:srgbClr val="3B1F7A"/>
+                </a:solidFill>
+              </a:defRPr>
+            </a:pPr>
+            <a:r>
+              <a:t>comparable to simulated annealing · penalty-QAOA = random</a:t>
             </a:r>
           </a:p>
         </p:txBody>
@@ -3699,7 +4274,7 @@
               </a:defRPr>
             </a:pPr>
             <a:r>
-              <a:t>Real hardware (ibm_kingston) and honest limits</a:t>
+              <a:t>Real IBM quantum hardware: ibm_kingston</a:t>
             </a:r>
           </a:p>
         </p:txBody>
@@ -3712,7 +4287,7 @@
         </p:nvSpPr>
         <p:spPr>
           <a:xfrm>
-            <a:off x="457200" y="1005840"/>
+            <a:off x="457200" y="960120"/>
             <a:ext cx="11247120" cy="457200"/>
           </a:xfrm>
           <a:prstGeom prst="rect">
@@ -3730,21 +4305,21 @@
               <a:spcAft>
                 <a:spcPts val="600"/>
               </a:spcAft>
-              <a:defRPr sz="1800" b="0">
+              <a:defRPr sz="2000" b="1">
                 <a:solidFill>
-                  <a:srgbClr val="444444"/>
+                  <a:srgbClr val="3B1F7A"/>
                 </a:solidFill>
               </a:defRPr>
             </a:pPr>
             <a:r>
-              <a:t>P(optimal) 0.51 raw → 0.65 post-selected vs 0.17 random · job db3b1bimb58s7387e0jg</a:t>
+              <a:t>ibm_kingston: 0.51 raw → 0.65 post-selected (random 0.17); top answer = true optimum</a:t>
             </a:r>
           </a:p>
         </p:txBody>
       </p:sp>
       <p:pic>
         <p:nvPicPr>
-          <p:cNvPr id="4" name="Picture 3" descr="noise_ladder.png"/>
+          <p:cNvPr id="4" name="Picture 3" descr="ibm_job_histogram.png"/>
           <p:cNvPicPr>
             <a:picLocks noChangeAspect="1"/>
           </p:cNvPicPr>
@@ -3758,17 +4333,55 @@
         </p:blipFill>
         <p:spPr>
           <a:xfrm>
-            <a:off x="365760" y="1554480"/>
-            <a:ext cx="5852160" cy="2784855"/>
+            <a:off x="365760" y="1600200"/>
+            <a:ext cx="5669280" cy="2451581"/>
           </a:xfrm>
           <a:prstGeom prst="rect">
             <a:avLst/>
           </a:prstGeom>
         </p:spPr>
       </p:pic>
+      <p:sp>
+        <p:nvSpPr>
+          <p:cNvPr id="5" name="TextBox 4"/>
+          <p:cNvSpPr txBox="1"/>
+          <p:nvPr/>
+        </p:nvSpPr>
+        <p:spPr>
+          <a:xfrm>
+            <a:off x="365760" y="4069080"/>
+            <a:ext cx="5669280" cy="822960"/>
+          </a:xfrm>
+          <a:prstGeom prst="rect">
+            <a:avLst/>
+          </a:prstGeom>
+          <a:noFill/>
+        </p:spPr>
+        <p:txBody>
+          <a:bodyPr wrap="square">
+            <a:spAutoFit/>
+          </a:bodyPr>
+          <a:lstStyle/>
+          <a:p>
+            <a:pPr>
+              <a:spcAft>
+                <a:spcPts val="600"/>
+              </a:spcAft>
+              <a:defRPr sz="2000" b="0">
+                <a:solidFill>
+                  <a:srgbClr val="444444"/>
+                </a:solidFill>
+              </a:defRPr>
+            </a:pPr>
+            <a:r>
+              <a:t>Real ibm_kingston output — tallest bar 1001 = optimal basket (RELIANCE+ITC), second 1100 = runner-up</a:t>
+            </a:r>
+          </a:p>
+        </p:txBody>
+      </p:sp>
       <p:pic>
         <p:nvPicPr>
-          <p:cNvPr id="5" name="Picture 4" descr="ibm_job_histogram.png"/>
+          <p:cNvPr id="6" name="Picture 5" descr="noise_ladder.png"/>
           <p:cNvPicPr>
             <a:picLocks noChangeAspect="1"/>
           </p:cNvPicPr>
@@ -3782,8 +4395,8 @@
         </p:blipFill>
         <p:spPr>
           <a:xfrm>
-            <a:off x="6355080" y="1600200"/>
-            <a:ext cx="5486400" cy="2372497"/>
+            <a:off x="6263640" y="1554480"/>
+            <a:ext cx="5577840" cy="2654315"/>
           </a:xfrm>
           <a:prstGeom prst="rect">
             <a:avLst/>
@@ -3792,52 +4405,14 @@
       </p:pic>
       <p:sp>
         <p:nvSpPr>
-          <p:cNvPr id="6" name="TextBox 5"/>
-          <p:cNvSpPr txBox="1"/>
-          <p:nvPr/>
-        </p:nvSpPr>
-        <p:spPr>
-          <a:xfrm>
-            <a:off x="6355080" y="4023360"/>
-            <a:ext cx="5486400" cy="731520"/>
-          </a:xfrm>
-          <a:prstGeom prst="rect">
-            <a:avLst/>
-          </a:prstGeom>
-          <a:noFill/>
-        </p:spPr>
-        <p:txBody>
-          <a:bodyPr wrap="square">
-            <a:spAutoFit/>
-          </a:bodyPr>
-          <a:lstStyle/>
-          <a:p>
-            <a:pPr>
-              <a:spcAft>
-                <a:spcPts val="600"/>
-              </a:spcAft>
-              <a:defRPr sz="1400" b="0">
-                <a:solidFill>
-                  <a:srgbClr val="3B1F7A"/>
-                </a:solidFill>
-              </a:defRPr>
-            </a:pPr>
-            <a:r>
-              <a:t>Real ibm_kingston output — tallest bar 1001 = optimal basket (RELIANCE+ITC), second 1100 = runner-up</a:t>
-            </a:r>
-          </a:p>
-        </p:txBody>
-      </p:sp>
-      <p:sp>
-        <p:nvSpPr>
           <p:cNvPr id="7" name="TextBox 6"/>
           <p:cNvSpPr txBox="1"/>
           <p:nvPr/>
         </p:nvSpPr>
         <p:spPr>
           <a:xfrm>
-            <a:off x="457200" y="4754880"/>
-            <a:ext cx="7863840" cy="1828800"/>
+            <a:off x="365760" y="5074920"/>
+            <a:ext cx="8229600" cy="1645920"/>
           </a:xfrm>
           <a:prstGeom prst="rect">
             <a:avLst/>
@@ -3861,51 +4436,45 @@
               </a:defRPr>
             </a:pPr>
             <a:r>
-              <a:t>• Symmetry post-selection = free error detection</a:t>
-            </a:r>
-          </a:p>
-          <a:p>
-            <a:pPr>
-              <a:spcAft>
-                <a:spcPts val="600"/>
-              </a:spcAft>
-              <a:defRPr sz="2000" b="0">
-                <a:solidFill>
-                  <a:srgbClr val="444444"/>
-                </a:solidFill>
-              </a:defRPr>
-            </a:pPr>
-            <a:r>
-              <a:t>• Classical brute force is still faster at this size: no quantum advantage claimed</a:t>
-            </a:r>
-          </a:p>
-          <a:p>
-            <a:pPr>
-              <a:spcAft>
-                <a:spcPts val="600"/>
-              </a:spcAft>
-              <a:defRPr sz="2000" b="0">
-                <a:solidFill>
-                  <a:srgbClr val="444444"/>
-                </a:solidFill>
-              </a:defRPr>
-            </a:pPr>
-            <a:r>
-              <a:t>• Next: more business constraints as circuit symmetries</a:t>
-            </a:r>
-          </a:p>
-        </p:txBody>
-      </p:sp>
-      <p:sp>
-        <p:nvSpPr>
-          <p:cNvPr id="8" name="TextBox 7"/>
+              <a:t>Limits: brute force is still faster at this size, so no quantum advantage is claimed; today's noise limits us to ~4–6 assets.</a:t>
+            </a:r>
+          </a:p>
+        </p:txBody>
+      </p:sp>
+      <p:pic>
+        <p:nvPicPr>
+          <p:cNvPr id="8" name="Picture 7" descr="qr_Repo.png"/>
+          <p:cNvPicPr>
+            <a:picLocks noChangeAspect="1"/>
+          </p:cNvPicPr>
+          <p:nvPr/>
+        </p:nvPicPr>
+        <p:blipFill>
+          <a:blip r:embed="rId4"/>
+          <a:stretch>
+            <a:fillRect/>
+          </a:stretch>
+        </p:blipFill>
+        <p:spPr>
+          <a:xfrm>
+            <a:off x="10698480" y="4800600"/>
+            <a:ext cx="1188720" cy="1188720"/>
+          </a:xfrm>
+          <a:prstGeom prst="rect">
+            <a:avLst/>
+          </a:prstGeom>
+        </p:spPr>
+      </p:pic>
+      <p:sp>
+        <p:nvSpPr>
+          <p:cNvPr id="9" name="TextBox 8"/>
           <p:cNvSpPr txBox="1"/>
           <p:nvPr/>
         </p:nvSpPr>
         <p:spPr>
           <a:xfrm>
-            <a:off x="8503920" y="5669280"/>
-            <a:ext cx="3474720" cy="914400"/>
+            <a:off x="10515600" y="5989320"/>
+            <a:ext cx="1554480" cy="365760"/>
           </a:xfrm>
           <a:prstGeom prst="rect">
             <a:avLst/>
@@ -3922,29 +4491,14 @@
               <a:spcAft>
                 <a:spcPts val="600"/>
               </a:spcAft>
-              <a:defRPr sz="1400" b="0">
+              <a:defRPr sz="2000" b="1">
                 <a:solidFill>
                   <a:srgbClr val="3B1F7A"/>
                 </a:solidFill>
               </a:defRPr>
             </a:pPr>
             <a:r>
-              <a:t>Repo: github.com/achintya007-arch/qfolio</a:t>
-            </a:r>
-          </a:p>
-          <a:p>
-            <a:pPr>
-              <a:spcAft>
-                <a:spcPts val="600"/>
-              </a:spcAft>
-              <a:defRPr sz="1400" b="0">
-                <a:solidFill>
-                  <a:srgbClr val="3B1F7A"/>
-                </a:solidFill>
-              </a:defRPr>
-            </a:pPr>
-            <a:r>
-              <a:t>Report: achintya007-arch.github.io/qfolio</a:t>
+              <a:t>Repo</a:t>
             </a:r>
           </a:p>
         </p:txBody>
@@ -4275,4 +4829,324 @@
   </a:objectDefaults>
   <a:extraClrSchemeLst/>
 </a:theme>
+</file>
+
+<file path=ppt/theme/theme2.xml><?xml version="1.0" encoding="utf-8"?>
+<a:theme xmlns:a="http://schemas.openxmlformats.org/drawingml/2006/main" name="Office Theme">
+  <a:themeElements>
+    <a:clrScheme name="Office">
+      <a:dk1>
+        <a:sysClr val="windowText" lastClr="000000"/>
+      </a:dk1>
+      <a:lt1>
+        <a:sysClr val="window" lastClr="FFFFFF"/>
+      </a:lt1>
+      <a:dk2>
+        <a:srgbClr val="1F497D"/>
+      </a:dk2>
+      <a:lt2>
+        <a:srgbClr val="EEECE1"/>
+      </a:lt2>
+      <a:accent1>
+        <a:srgbClr val="4F81BD"/>
+      </a:accent1>
+      <a:accent2>
+        <a:srgbClr val="C0504D"/>
+      </a:accent2>
+      <a:accent3>
+        <a:srgbClr val="9BBB59"/>
+      </a:accent3>
+      <a:accent4>
+        <a:srgbClr val="8064A2"/>
+      </a:accent4>
+      <a:accent5>
+        <a:srgbClr val="4BACC6"/>
+      </a:accent5>
+      <a:accent6>
+        <a:srgbClr val="F79646"/>
+      </a:accent6>
+      <a:hlink>
+        <a:srgbClr val="0000FF"/>
+      </a:hlink>
+      <a:folHlink>
+        <a:srgbClr val="800080"/>
+      </a:folHlink>
+    </a:clrScheme>
+    <a:fontScheme name="Office">
+      <a:majorFont>
+        <a:latin typeface="Calibri"/>
+        <a:ea typeface=""/>
+        <a:cs typeface=""/>
+        <a:font script="Jpan" typeface="ＭＳ Ｐゴシック"/>
+        <a:font script="Hang" typeface="맑은 고딕"/>
+        <a:font script="Hans" typeface="宋体"/>
+        <a:font script="Hant" typeface="新細明體"/>
+        <a:font script="Arab" typeface="Times New Roman"/>
+        <a:font script="Hebr" typeface="Times New Roman"/>
+        <a:font script="Thai" typeface="Angsana New"/>
+        <a:font script="Ethi" typeface="Nyala"/>
+        <a:font script="Beng" typeface="Vrinda"/>
+        <a:font script="Gujr" typeface="Shruti"/>
+        <a:font script="Khmr" typeface="MoolBoran"/>
+        <a:font script="Knda" typeface="Tunga"/>
+        <a:font script="Guru" typeface="Raavi"/>
+        <a:font script="Cans" typeface="Euphemia"/>
+        <a:font script="Cher" typeface="Plantagenet Cherokee"/>
+        <a:font script="Yiii" typeface="Microsoft Yi Baiti"/>
+        <a:font script="Tibt" typeface="Microsoft Himalaya"/>
+        <a:font script="Thaa" typeface="MV Boli"/>
+        <a:font script="Deva" typeface="Mangal"/>
+        <a:font script="Telu" typeface="Gautami"/>
+        <a:font script="Taml" typeface="Latha"/>
+        <a:font script="Syrc" typeface="Estrangelo Edessa"/>
+        <a:font script="Orya" typeface="Kalinga"/>
+        <a:font script="Mlym" typeface="Kartika"/>
+        <a:font script="Laoo" typeface="DokChampa"/>
+        <a:font script="Sinh" typeface="Iskoola Pota"/>
+        <a:font script="Mong" typeface="Mongolian Baiti"/>
+        <a:font script="Viet" typeface="Times New Roman"/>
+        <a:font script="Uigh" typeface="Microsoft Uighur"/>
+        <a:font script="Geor" typeface="Sylfaen"/>
+      </a:majorFont>
+      <a:minorFont>
+        <a:latin typeface="Calibri"/>
+        <a:ea typeface=""/>
+        <a:cs typeface=""/>
+        <a:font script="Jpan" typeface="ＭＳ Ｐゴシック"/>
+        <a:font script="Hang" typeface="맑은 고딕"/>
+        <a:font script="Hans" typeface="宋体"/>
+        <a:font script="Hant" typeface="新細明體"/>
+        <a:font script="Arab" typeface="Arial"/>
+        <a:font script="Hebr" typeface="Arial"/>
+        <a:font script="Thai" typeface="Cordia New"/>
+        <a:font script="Ethi" typeface="Nyala"/>
+        <a:font script="Beng" typeface="Vrinda"/>
+        <a:font script="Gujr" typeface="Shruti"/>
+        <a:font script="Khmr" typeface="DaunPenh"/>
+        <a:font script="Knda" typeface="Tunga"/>
+        <a:font script="Guru" typeface="Raavi"/>
+        <a:font script="Cans" typeface="Euphemia"/>
+        <a:font script="Cher" typeface="Plantagenet Cherokee"/>
+        <a:font script="Yiii" typeface="Microsoft Yi Baiti"/>
+        <a:font script="Tibt" typeface="Microsoft Himalaya"/>
+        <a:font script="Thaa" typeface="MV Boli"/>
+        <a:font script="Deva" typeface="Mangal"/>
+        <a:font script="Telu" typeface="Gautami"/>
+        <a:font script="Taml" typeface="Latha"/>
+        <a:font script="Syrc" typeface="Estrangelo Edessa"/>
+        <a:font script="Orya" typeface="Kalinga"/>
+        <a:font script="Mlym" typeface="Kartika"/>
+        <a:font script="Laoo" typeface="DokChampa"/>
+        <a:font script="Sinh" typeface="Iskoola Pota"/>
+        <a:font script="Mong" typeface="Mongolian Baiti"/>
+        <a:font script="Viet" typeface="Arial"/>
+        <a:font script="Uigh" typeface="Microsoft Uighur"/>
+        <a:font script="Geor" typeface="Sylfaen"/>
+      </a:minorFont>
+    </a:fontScheme>
+    <a:fmtScheme name="Office">
+      <a:fillStyleLst>
+        <a:solidFill>
+          <a:schemeClr val="phClr"/>
+        </a:solidFill>
+        <a:gradFill rotWithShape="1">
+          <a:gsLst>
+            <a:gs pos="0">
+              <a:schemeClr val="phClr">
+                <a:tint val="50000"/>
+                <a:satMod val="300000"/>
+              </a:schemeClr>
+            </a:gs>
+            <a:gs pos="35000">
+              <a:schemeClr val="phClr">
+                <a:tint val="37000"/>
+                <a:satMod val="300000"/>
+              </a:schemeClr>
+            </a:gs>
+            <a:gs pos="100000">
+              <a:schemeClr val="phClr">
+                <a:tint val="15000"/>
+                <a:satMod val="350000"/>
+              </a:schemeClr>
+            </a:gs>
+          </a:gsLst>
+          <a:lin ang="16200000" scaled="1"/>
+        </a:gradFill>
+        <a:gradFill rotWithShape="1">
+          <a:gsLst>
+            <a:gs pos="0">
+              <a:schemeClr val="phClr">
+                <a:tint val="100000"/>
+                <a:shade val="100000"/>
+                <a:satMod val="130000"/>
+              </a:schemeClr>
+            </a:gs>
+            <a:gs pos="100000">
+              <a:schemeClr val="phClr">
+                <a:tint val="50000"/>
+                <a:shade val="100000"/>
+                <a:satMod val="350000"/>
+              </a:schemeClr>
+            </a:gs>
+          </a:gsLst>
+          <a:lin ang="16200000" scaled="0"/>
+        </a:gradFill>
+      </a:fillStyleLst>
+      <a:lnStyleLst>
+        <a:ln w="9525" cap="flat" cmpd="sng" algn="ctr">
+          <a:solidFill>
+            <a:schemeClr val="phClr">
+              <a:shade val="95000"/>
+              <a:satMod val="105000"/>
+            </a:schemeClr>
+          </a:solidFill>
+          <a:prstDash val="solid"/>
+        </a:ln>
+        <a:ln w="25400" cap="flat" cmpd="sng" algn="ctr">
+          <a:solidFill>
+            <a:schemeClr val="phClr"/>
+          </a:solidFill>
+          <a:prstDash val="solid"/>
+        </a:ln>
+        <a:ln w="38100" cap="flat" cmpd="sng" algn="ctr">
+          <a:solidFill>
+            <a:schemeClr val="phClr"/>
+          </a:solidFill>
+          <a:prstDash val="solid"/>
+        </a:ln>
+      </a:lnStyleLst>
+      <a:effectStyleLst>
+        <a:effectStyle>
+          <a:effectLst>
+            <a:outerShdw blurRad="40000" dist="20000" dir="5400000" rotWithShape="0">
+              <a:srgbClr val="000000">
+                <a:alpha val="38000"/>
+              </a:srgbClr>
+            </a:outerShdw>
+          </a:effectLst>
+        </a:effectStyle>
+        <a:effectStyle>
+          <a:effectLst>
+            <a:outerShdw blurRad="40000" dist="23000" dir="5400000" rotWithShape="0">
+              <a:srgbClr val="000000">
+                <a:alpha val="35000"/>
+              </a:srgbClr>
+            </a:outerShdw>
+          </a:effectLst>
+        </a:effectStyle>
+        <a:effectStyle>
+          <a:effectLst>
+            <a:outerShdw blurRad="40000" dist="23000" dir="5400000" rotWithShape="0">
+              <a:srgbClr val="000000">
+                <a:alpha val="35000"/>
+              </a:srgbClr>
+            </a:outerShdw>
+          </a:effectLst>
+          <a:scene3d>
+            <a:camera prst="orthographicFront">
+              <a:rot lat="0" lon="0" rev="0"/>
+            </a:camera>
+            <a:lightRig rig="threePt" dir="t">
+              <a:rot lat="0" lon="0" rev="1200000"/>
+            </a:lightRig>
+          </a:scene3d>
+          <a:sp3d>
+            <a:bevelT w="63500" h="25400"/>
+          </a:sp3d>
+        </a:effectStyle>
+      </a:effectStyleLst>
+      <a:bgFillStyleLst>
+        <a:solidFill>
+          <a:schemeClr val="phClr"/>
+        </a:solidFill>
+        <a:gradFill rotWithShape="1">
+          <a:gsLst>
+            <a:gs pos="0">
+              <a:schemeClr val="phClr">
+                <a:tint val="40000"/>
+                <a:satMod val="350000"/>
+              </a:schemeClr>
+            </a:gs>
+            <a:gs pos="40000">
+              <a:schemeClr val="phClr">
+                <a:tint val="45000"/>
+                <a:shade val="99000"/>
+                <a:satMod val="350000"/>
+              </a:schemeClr>
+            </a:gs>
+            <a:gs pos="100000">
+              <a:schemeClr val="phClr">
+                <a:shade val="20000"/>
+                <a:satMod val="255000"/>
+              </a:schemeClr>
+            </a:gs>
+          </a:gsLst>
+          <a:path path="circle">
+            <a:fillToRect l="50000" t="-80000" r="50000" b="180000"/>
+          </a:path>
+        </a:gradFill>
+        <a:gradFill rotWithShape="1">
+          <a:gsLst>
+            <a:gs pos="0">
+              <a:schemeClr val="phClr">
+                <a:tint val="80000"/>
+                <a:satMod val="300000"/>
+              </a:schemeClr>
+            </a:gs>
+            <a:gs pos="100000">
+              <a:schemeClr val="phClr">
+                <a:shade val="30000"/>
+                <a:satMod val="200000"/>
+              </a:schemeClr>
+            </a:gs>
+          </a:gsLst>
+          <a:path path="circle">
+            <a:fillToRect l="50000" t="50000" r="50000" b="50000"/>
+          </a:path>
+        </a:gradFill>
+      </a:bgFillStyleLst>
+    </a:fmtScheme>
+  </a:themeElements>
+  <a:objectDefaults>
+    <a:spDef>
+      <a:spPr/>
+      <a:bodyPr/>
+      <a:lstStyle/>
+      <a:style>
+        <a:lnRef idx="1">
+          <a:schemeClr val="accent1"/>
+        </a:lnRef>
+        <a:fillRef idx="3">
+          <a:schemeClr val="accent1"/>
+        </a:fillRef>
+        <a:effectRef idx="2">
+          <a:schemeClr val="accent1"/>
+        </a:effectRef>
+        <a:fontRef idx="minor">
+          <a:schemeClr val="lt1"/>
+        </a:fontRef>
+      </a:style>
+    </a:spDef>
+    <a:lnDef>
+      <a:spPr/>
+      <a:bodyPr/>
+      <a:lstStyle/>
+      <a:style>
+        <a:lnRef idx="2">
+          <a:schemeClr val="accent1"/>
+        </a:lnRef>
+        <a:fillRef idx="0">
+          <a:schemeClr val="accent1"/>
+        </a:fillRef>
+        <a:effectRef idx="1">
+          <a:schemeClr val="accent1"/>
+        </a:effectRef>
+        <a:fontRef idx="minor">
+          <a:schemeClr val="tx1"/>
+        </a:fontRef>
+      </a:style>
+    </a:lnDef>
+  </a:objectDefaults>
+  <a:extraClrSchemeLst/>
+</a:theme>
 </file>
</xml_diff>

<commit_message>
docs: Streamlit URL in README, brief, Pages landing page and slide QR code
Co-Authored-By: Claude Opus 5.5 <noreply@anthropic.com>
</commit_message>
<xml_diff>
--- a/docs/slides.pptx
+++ b/docs/slides.pptx
@@ -4499,6 +4499,68 @@
             </a:pPr>
             <a:r>
               <a:t>Repo</a:t>
+            </a:r>
+          </a:p>
+        </p:txBody>
+      </p:sp>
+      <p:pic>
+        <p:nvPicPr>
+          <p:cNvPr id="10" name="Picture 9" descr="qr_Live demo.png"/>
+          <p:cNvPicPr>
+            <a:picLocks noChangeAspect="1"/>
+          </p:cNvPicPr>
+          <p:nvPr/>
+        </p:nvPicPr>
+        <p:blipFill>
+          <a:blip r:embed="rId5"/>
+          <a:stretch>
+            <a:fillRect/>
+          </a:stretch>
+        </p:blipFill>
+        <p:spPr>
+          <a:xfrm>
+            <a:off x="9189719" y="4800600"/>
+            <a:ext cx="1188720" cy="1188720"/>
+          </a:xfrm>
+          <a:prstGeom prst="rect">
+            <a:avLst/>
+          </a:prstGeom>
+        </p:spPr>
+      </p:pic>
+      <p:sp>
+        <p:nvSpPr>
+          <p:cNvPr id="11" name="TextBox 10"/>
+          <p:cNvSpPr txBox="1"/>
+          <p:nvPr/>
+        </p:nvSpPr>
+        <p:spPr>
+          <a:xfrm>
+            <a:off x="9006840" y="5989320"/>
+            <a:ext cx="1554480" cy="365760"/>
+          </a:xfrm>
+          <a:prstGeom prst="rect">
+            <a:avLst/>
+          </a:prstGeom>
+          <a:noFill/>
+        </p:spPr>
+        <p:txBody>
+          <a:bodyPr wrap="square">
+            <a:spAutoFit/>
+          </a:bodyPr>
+          <a:lstStyle/>
+          <a:p>
+            <a:pPr>
+              <a:spcAft>
+                <a:spcPts val="600"/>
+              </a:spcAft>
+              <a:defRPr sz="2000" b="1">
+                <a:solidFill>
+                  <a:srgbClr val="3B1F7A"/>
+                </a:solidFill>
+              </a:defRPr>
+            </a:pPr>
+            <a:r>
+              <a:t>Live demo</a:t>
             </a:r>
           </a:p>
         </p:txBody>

</xml_diff>

<commit_message>
docs: update author name
Co-Authored-By: Claude Opus 5.5 <noreply@anthropic.com>
</commit_message>
<xml_diff>
--- a/docs/slides.pptx
+++ b/docs/slides.pptx
@@ -504,7 +504,7 @@
           <a:lstStyle/>
           <a:p>
             <a:r>
-              <a:t>Robo-advisors in India sell model baskets: a few stocks, equal weights, for a given risk profile. Choosing which k stocks go in is a combinatorial problem. Here I pick 3 of 6 NSE large caps, which is 20 possible baskets; each dot on this chart is one of them. We want return up and risk down, and the client's risk aversion q sets the trade-off. The blue star is the best basket for q = 0.5, and the orange diamond is a very close runner-up. At 20 baskets a laptop checks them all instantly, but the count explodes as C(n,k), so it is a natural test bed for quantum optimisation.</a:t>
+              <a:t>Hi, I'm Akella Ahlad Achintya. Robo-advisors in India sell model baskets: a few stocks, equal weights, for a given risk profile. Choosing which k stocks go in is a combinatorial problem. Here I pick 3 of 6 NSE large caps, which is 20 possible baskets; each dot on this chart is one of them. We want return up and risk down, and the client's risk aversion q sets the trade-off. The blue star is the best basket for q = 0.5, and the orange diamond is a very close runner-up. At 20 baskets a laptop checks them all instantly, but the count explodes as C(n,k), so it is a natural test bed for quantum optimisation.</a:t>
             </a:r>
           </a:p>
         </p:txBody>
@@ -644,7 +644,7 @@
           <a:lstStyle/>
           <a:p>
             <a:r>
-              <a:t>Then I ran the same circuit on IBM's ibm_kingston, with 4 stocks and 2 picked. On the left is the raw output from the IBM dashboard: the tallest bar is the optimal basket and the second is the runner-up. Noise lets some invalid baskets through, about 22% of shots. The ideal circuit can never produce them, so I simply throw them away. That is free error detection. The optimal basket goes from 51% to 65%, against 17% for a random guess. Honest limits: at this size a laptop solves it instantly, so I claim no quantum advantage. The point is that building business constraints into the circuit is what makes quantum optimisation work at all. Code and live demo are behind the QR codes.</a:t>
+              <a:t>Then I ran the same circuit on IBM's ibm_kingston, with 4 stocks and 2 picked. On the left is the raw output from the IBM dashboard: the tallest bar is the optimal basket and the second is the runner-up. Noise lets some invalid baskets through, about 22% of shots. The ideal circuit can never produce them, so I simply throw them away. That is free error detection. The optimal basket goes from 51% to 65%, against 17% for a random guess. Honest limits: at this size a laptop solves it instantly, so I claim no quantum advantage. The point is that building business constraints into the circuit is what makes quantum optimisation work at all. Code and live demo are behind the QR codes. Thank you, I'm Akella Ahlad Achintya.</a:t>
             </a:r>
           </a:p>
         </p:txBody>
@@ -3814,6 +3814,59 @@
             </a:pPr>
             <a:r>
               <a:t>Goal: find the best basket for a client's risk aversion q.</a:t>
+            </a:r>
+          </a:p>
+        </p:txBody>
+      </p:sp>
+      <p:sp>
+        <p:nvSpPr>
+          <p:cNvPr id="6" name="TextBox 5"/>
+          <p:cNvSpPr txBox="1"/>
+          <p:nvPr/>
+        </p:nvSpPr>
+        <p:spPr>
+          <a:xfrm>
+            <a:off x="8412480" y="5669280"/>
+            <a:ext cx="3566160" cy="914400"/>
+          </a:xfrm>
+          <a:prstGeom prst="rect">
+            <a:avLst/>
+          </a:prstGeom>
+          <a:noFill/>
+        </p:spPr>
+        <p:txBody>
+          <a:bodyPr wrap="square">
+            <a:spAutoFit/>
+          </a:bodyPr>
+          <a:lstStyle/>
+          <a:p>
+            <a:pPr>
+              <a:spcAft>
+                <a:spcPts val="600"/>
+              </a:spcAft>
+              <a:defRPr sz="2000" b="0">
+                <a:solidFill>
+                  <a:srgbClr val="3B1F7A"/>
+                </a:solidFill>
+              </a:defRPr>
+            </a:pPr>
+            <a:r>
+              <a:t>Akella Ahlad Achintya</a:t>
+            </a:r>
+          </a:p>
+          <a:p>
+            <a:pPr>
+              <a:spcAft>
+                <a:spcPts val="600"/>
+              </a:spcAft>
+              <a:defRPr sz="2000" b="0">
+                <a:solidFill>
+                  <a:srgbClr val="3B1F7A"/>
+                </a:solidFill>
+              </a:defRPr>
+            </a:pPr>
+            <a:r>
+              <a:t>Qiskit Fall Fest 2026 · Track I2</a:t>
             </a:r>
           </a:p>
         </p:txBody>

</xml_diff>

<commit_message>
docs(slides): add title slide with one-sentence pitch in speaker notes
Co-Authored-By: Claude Opus 5.5 <noreply@anthropic.com>
</commit_message>
<xml_diff>
--- a/docs/slides.pptx
+++ b/docs/slides.pptx
@@ -8,6 +8,7 @@
     <p:sldId id="256" r:id="rId7"/>
     <p:sldId id="257" r:id="rId9"/>
     <p:sldId id="258" r:id="rId10"/>
+    <p:sldId id="259" r:id="rId11"/>
   </p:sldIdLst>
   <p:sldSz cx="12191695" cy="6858000" type="screen4x3"/>
   <p:notesSz cx="6858000" cy="9144000"/>
@@ -504,7 +505,7 @@
           <a:lstStyle/>
           <a:p>
             <a:r>
-              <a:t>Hi, I'm Akella Ahlad Achintya. Robo-advisors in India sell model baskets: a few stocks, equal weights, for a given risk profile. Choosing which k stocks go in is a combinatorial problem. Here I pick 3 of 6 NSE large caps, which is 20 possible baskets; each dot on this chart is one of them. We want return up and risk down, and the client's risk aversion q sets the trade-off. The blue star is the best basket for q = 0.5, and the orange diamond is a very close runner-up. At 20 baskets a laptop checks them all instantly, but the count explodes as C(n,k), so it is a natural test bed for quantum optimisation.</a:t>
+              <a:t>Standard QAOA treats 'pick exactly k stocks' as a penalty and ends up no better than random guessing, so I built the constraint into the circuit: every shot is a valid portfolio, it finds the optimal basket about 7× more often than chance, and the same symmetry lets me throw out hardware errors for free on a real IBM quantum computer.</a:t>
             </a:r>
           </a:p>
         </p:txBody>
@@ -574,7 +575,7 @@
           <a:lstStyle/>
           <a:p>
             <a:r>
-              <a:t>The textbook way to say 'exactly 3 stocks' is a penalty term in the cost. I tested it carefully: only 75% of its samples are valid baskets, and it finds the best one 4% of the time, the same as random guessing at 5%. So I moved the constraint into the circuit. A Dicke state starts in an equal mix of only the valid baskets, and an XY mixer swaps stocks in and out without changing the count. Every shot is a real portfolio. Over 24 test instances the best basket comes up 34% of the time, about the same as simulated annealing at 36%. Grey bars are classical baselines, blue is ours, orange is the penalty approach.</a:t>
+              <a:t>Hi, I'm Akella Ahlad Achintya. Robo-advisors in India sell model baskets: a few stocks, equal weights, for a given risk profile. Choosing which k stocks go in is a combinatorial problem. Here I pick 3 of 6 NSE large caps, which is 20 possible baskets; each dot on this chart is one of them. We want return up and risk down, and the client's risk aversion q sets the trade-off. The blue star is the best basket for q = 0.5, and the orange diamond is a very close runner-up. At 20 baskets a laptop checks them all instantly, but the count explodes as C(n,k), so it is a natural test bed for quantum optimisation.</a:t>
             </a:r>
           </a:p>
         </p:txBody>
@@ -600,6 +601,76 @@
 </file>
 
 <file path=ppt/notesSlides/notesSlide3.xml><?xml version="1.0" encoding="utf-8"?>
+<p:notes xmlns:a="http://schemas.openxmlformats.org/drawingml/2006/main" xmlns:p="http://schemas.openxmlformats.org/presentationml/2006/main" xmlns:r="http://schemas.openxmlformats.org/officeDocument/2006/relationships">
+  <p:cSld>
+    <p:spTree>
+      <p:nvGrpSpPr>
+        <p:cNvPr id="1" name=""/>
+        <p:cNvGrpSpPr/>
+        <p:nvPr/>
+      </p:nvGrpSpPr>
+      <p:grpSpPr>
+        <a:xfrm>
+          <a:off x="0" y="0"/>
+          <a:ext cx="0" cy="0"/>
+          <a:chOff x="0" y="0"/>
+          <a:chExt cx="0" cy="0"/>
+        </a:xfrm>
+      </p:grpSpPr>
+      <p:sp>
+        <p:nvSpPr>
+          <p:cNvPr id="2" name="Slide Image Placeholder 1"/>
+          <p:cNvSpPr>
+            <a:spLocks noGrp="1"/>
+          </p:cNvSpPr>
+          <p:nvPr>
+            <p:ph type="sldImg" idx="2"/>
+          </p:nvPr>
+        </p:nvSpPr>
+        <p:spPr/>
+      </p:sp>
+      <p:sp>
+        <p:nvSpPr>
+          <p:cNvPr id="3" name="Notes Placeholder 2"/>
+          <p:cNvSpPr>
+            <a:spLocks noGrp="1"/>
+          </p:cNvSpPr>
+          <p:nvPr>
+            <p:ph type="body" idx="3" sz="quarter"/>
+          </p:nvPr>
+        </p:nvSpPr>
+        <p:spPr/>
+        <p:txBody>
+          <a:bodyPr/>
+          <a:lstStyle/>
+          <a:p>
+            <a:r>
+              <a:t>The textbook way to say 'exactly 3 stocks' is a penalty term in the cost. I tested it carefully: only 75% of its samples are valid baskets, and it finds the best one 4% of the time, the same as random guessing at 5%. So I moved the constraint into the circuit. A Dicke state starts in an equal mix of only the valid baskets, and an XY mixer swaps stocks in and out without changing the count. Every shot is a real portfolio. Over 24 test instances the best basket comes up 34% of the time, about the same as simulated annealing at 36%. Grey bars are classical baselines, blue is ours, orange is the penalty approach.</a:t>
+            </a:r>
+          </a:p>
+        </p:txBody>
+      </p:sp>
+      <p:sp>
+        <p:nvSpPr>
+          <p:cNvPr id="4" name="Slide Number Placeholder 3"/>
+          <p:cNvSpPr>
+            <a:spLocks noGrp="1"/>
+          </p:cNvSpPr>
+          <p:nvPr>
+            <p:ph type="sldNum" idx="5" sz="quarter"/>
+          </p:nvPr>
+        </p:nvSpPr>
+        <p:spPr/>
+      </p:sp>
+    </p:spTree>
+  </p:cSld>
+  <p:clrMapOvr>
+    <a:masterClrMapping/>
+  </p:clrMapOvr>
+</p:notes>
+</file>
+
+<file path=ppt/notesSlides/notesSlide4.xml><?xml version="1.0" encoding="utf-8"?>
 <p:notes xmlns:a="http://schemas.openxmlformats.org/drawingml/2006/main" xmlns:p="http://schemas.openxmlformats.org/presentationml/2006/main" xmlns:r="http://schemas.openxmlformats.org/officeDocument/2006/relationships">
   <p:cSld>
     <p:spTree>
@@ -3658,8 +3729,8 @@
         </p:nvSpPr>
         <p:spPr>
           <a:xfrm>
-            <a:off x="457200" y="274320"/>
-            <a:ext cx="11247120" cy="822960"/>
+            <a:off x="731520" y="2011680"/>
+            <a:ext cx="10698480" cy="1645920"/>
           </a:xfrm>
           <a:prstGeom prst="rect">
             <a:avLst/>
@@ -3676,14 +3747,14 @@
               <a:spcAft>
                 <a:spcPts val="600"/>
               </a:spcAft>
-              <a:defRPr sz="3400" b="1">
+              <a:defRPr sz="4400" b="1">
                 <a:solidFill>
                   <a:srgbClr val="3B1F7A"/>
                 </a:solidFill>
               </a:defRPr>
             </a:pPr>
             <a:r>
-              <a:t>Picking the best 3 of 6 stocks, on a quantum computer</a:t>
+              <a:t>Q-Folio: Constraint-Preserving QAOA for Portfolio Selection</a:t>
             </a:r>
           </a:p>
         </p:txBody>
@@ -3696,8 +3767,61 @@
         </p:nvSpPr>
         <p:spPr>
           <a:xfrm>
-            <a:off x="457200" y="960120"/>
-            <a:ext cx="11247120" cy="457200"/>
+            <a:off x="731520" y="3749039"/>
+            <a:ext cx="10698480" cy="914400"/>
+          </a:xfrm>
+          <a:prstGeom prst="rect">
+            <a:avLst/>
+          </a:prstGeom>
+          <a:noFill/>
+        </p:spPr>
+        <p:txBody>
+          <a:bodyPr wrap="square">
+            <a:spAutoFit/>
+          </a:bodyPr>
+          <a:lstStyle/>
+          <a:p>
+            <a:pPr>
+              <a:spcAft>
+                <a:spcPts val="600"/>
+              </a:spcAft>
+              <a:defRPr sz="2400" b="0">
+                <a:solidFill>
+                  <a:srgbClr val="444444"/>
+                </a:solidFill>
+              </a:defRPr>
+            </a:pPr>
+            <a:r>
+              <a:t>Qiskit Fall Fest 2026 · Industry Track I2</a:t>
+            </a:r>
+          </a:p>
+          <a:p>
+            <a:pPr>
+              <a:spcAft>
+                <a:spcPts val="600"/>
+              </a:spcAft>
+              <a:defRPr sz="2400" b="0">
+                <a:solidFill>
+                  <a:srgbClr val="444444"/>
+                </a:solidFill>
+              </a:defRPr>
+            </a:pPr>
+            <a:r>
+              <a:t>Akella Ahlad Achintya · GITAM University, Bengaluru</a:t>
+            </a:r>
+          </a:p>
+        </p:txBody>
+      </p:sp>
+      <p:sp>
+        <p:nvSpPr>
+          <p:cNvPr id="4" name="TextBox 3"/>
+          <p:cNvSpPr txBox="1"/>
+          <p:nvPr/>
+        </p:nvSpPr>
+        <p:spPr>
+          <a:xfrm>
+            <a:off x="731520" y="4846320"/>
+            <a:ext cx="10698480" cy="457200"/>
           </a:xfrm>
           <a:prstGeom prst="rect">
             <a:avLst/>
@@ -3716,157 +3840,12 @@
               </a:spcAft>
               <a:defRPr sz="2000" b="0">
                 <a:solidFill>
-                  <a:srgbClr val="444444"/>
+                  <a:srgbClr val="2A78D6"/>
                 </a:solidFill>
               </a:defRPr>
             </a:pPr>
             <a:r>
-              <a:t>Robo-advisor model baskets · NSE large caps · return ↑ risk ↓</a:t>
-            </a:r>
-          </a:p>
-        </p:txBody>
-      </p:sp>
-      <p:pic>
-        <p:nvPicPr>
-          <p:cNvPr id="4" name="Picture 3" descr="frontier.png"/>
-          <p:cNvPicPr>
-            <a:picLocks noChangeAspect="1"/>
-          </p:cNvPicPr>
-          <p:nvPr/>
-        </p:nvPicPr>
-        <p:blipFill>
-          <a:blip r:embed="rId2"/>
-          <a:stretch>
-            <a:fillRect/>
-          </a:stretch>
-        </p:blipFill>
-        <p:spPr>
-          <a:xfrm>
-            <a:off x="457200" y="1600200"/>
-            <a:ext cx="7801332" cy="5029200"/>
-          </a:xfrm>
-          <a:prstGeom prst="rect">
-            <a:avLst/>
-          </a:prstGeom>
-        </p:spPr>
-      </p:pic>
-      <p:sp>
-        <p:nvSpPr>
-          <p:cNvPr id="5" name="TextBox 4"/>
-          <p:cNvSpPr txBox="1"/>
-          <p:nvPr/>
-        </p:nvSpPr>
-        <p:spPr>
-          <a:xfrm>
-            <a:off x="8412480" y="2011680"/>
-            <a:ext cx="3474720" cy="4572000"/>
-          </a:xfrm>
-          <a:prstGeom prst="rect">
-            <a:avLst/>
-          </a:prstGeom>
-          <a:noFill/>
-        </p:spPr>
-        <p:txBody>
-          <a:bodyPr wrap="square">
-            <a:spAutoFit/>
-          </a:bodyPr>
-          <a:lstStyle/>
-          <a:p>
-            <a:pPr>
-              <a:spcAft>
-                <a:spcPts val="600"/>
-              </a:spcAft>
-              <a:defRPr sz="2000" b="0">
-                <a:solidFill>
-                  <a:srgbClr val="444444"/>
-                </a:solidFill>
-              </a:defRPr>
-            </a:pPr>
-            <a:r>
-              <a:t>All C(6,3) = 20 baskets on the risk/return plane.</a:t>
-            </a:r>
-          </a:p>
-          <a:p>
-            <a:pPr>
-              <a:spcAft>
-                <a:spcPts val="600"/>
-              </a:spcAft>
-              <a:defRPr sz="2000" b="0">
-                <a:solidFill>
-                  <a:srgbClr val="444444"/>
-                </a:solidFill>
-              </a:defRPr>
-            </a:pPr>
-            <a:r>
-              <a:t>Basket count grows as C(n,k): ~185 000 for 10-of-20.</a:t>
-            </a:r>
-          </a:p>
-          <a:p>
-            <a:pPr>
-              <a:spcAft>
-                <a:spcPts val="600"/>
-              </a:spcAft>
-              <a:defRPr sz="2000" b="0">
-                <a:solidFill>
-                  <a:srgbClr val="444444"/>
-                </a:solidFill>
-              </a:defRPr>
-            </a:pPr>
-            <a:r>
-              <a:t>Goal: find the best basket for a client's risk aversion q.</a:t>
-            </a:r>
-          </a:p>
-        </p:txBody>
-      </p:sp>
-      <p:sp>
-        <p:nvSpPr>
-          <p:cNvPr id="6" name="TextBox 5"/>
-          <p:cNvSpPr txBox="1"/>
-          <p:nvPr/>
-        </p:nvSpPr>
-        <p:spPr>
-          <a:xfrm>
-            <a:off x="8412480" y="5669280"/>
-            <a:ext cx="3566160" cy="914400"/>
-          </a:xfrm>
-          <a:prstGeom prst="rect">
-            <a:avLst/>
-          </a:prstGeom>
-          <a:noFill/>
-        </p:spPr>
-        <p:txBody>
-          <a:bodyPr wrap="square">
-            <a:spAutoFit/>
-          </a:bodyPr>
-          <a:lstStyle/>
-          <a:p>
-            <a:pPr>
-              <a:spcAft>
-                <a:spcPts val="600"/>
-              </a:spcAft>
-              <a:defRPr sz="2000" b="0">
-                <a:solidFill>
-                  <a:srgbClr val="3B1F7A"/>
-                </a:solidFill>
-              </a:defRPr>
-            </a:pPr>
-            <a:r>
-              <a:t>Akella Ahlad Achintya</a:t>
-            </a:r>
-          </a:p>
-          <a:p>
-            <a:pPr>
-              <a:spcAft>
-                <a:spcPts val="600"/>
-              </a:spcAft>
-              <a:defRPr sz="2000" b="0">
-                <a:solidFill>
-                  <a:srgbClr val="3B1F7A"/>
-                </a:solidFill>
-              </a:defRPr>
-            </a:pPr>
-            <a:r>
-              <a:t>Qiskit Fall Fest 2026 · Track I2</a:t>
+              <a:t>Real results on IBM Quantum ibm_kingston</a:t>
             </a:r>
           </a:p>
         </p:txBody>
@@ -3922,6 +3901,245 @@
               </a:defRPr>
             </a:pPr>
             <a:r>
+              <a:t>Picking the best 3 of 6 stocks, on a quantum computer</a:t>
+            </a:r>
+          </a:p>
+        </p:txBody>
+      </p:sp>
+      <p:sp>
+        <p:nvSpPr>
+          <p:cNvPr id="3" name="TextBox 2"/>
+          <p:cNvSpPr txBox="1"/>
+          <p:nvPr/>
+        </p:nvSpPr>
+        <p:spPr>
+          <a:xfrm>
+            <a:off x="457200" y="960120"/>
+            <a:ext cx="11247120" cy="457200"/>
+          </a:xfrm>
+          <a:prstGeom prst="rect">
+            <a:avLst/>
+          </a:prstGeom>
+          <a:noFill/>
+        </p:spPr>
+        <p:txBody>
+          <a:bodyPr wrap="square">
+            <a:spAutoFit/>
+          </a:bodyPr>
+          <a:lstStyle/>
+          <a:p>
+            <a:pPr>
+              <a:spcAft>
+                <a:spcPts val="600"/>
+              </a:spcAft>
+              <a:defRPr sz="2000" b="0">
+                <a:solidFill>
+                  <a:srgbClr val="444444"/>
+                </a:solidFill>
+              </a:defRPr>
+            </a:pPr>
+            <a:r>
+              <a:t>Robo-advisor model baskets · NSE large caps · return ↑ risk ↓</a:t>
+            </a:r>
+          </a:p>
+        </p:txBody>
+      </p:sp>
+      <p:pic>
+        <p:nvPicPr>
+          <p:cNvPr id="4" name="Picture 3" descr="frontier.png"/>
+          <p:cNvPicPr>
+            <a:picLocks noChangeAspect="1"/>
+          </p:cNvPicPr>
+          <p:nvPr/>
+        </p:nvPicPr>
+        <p:blipFill>
+          <a:blip r:embed="rId2"/>
+          <a:stretch>
+            <a:fillRect/>
+          </a:stretch>
+        </p:blipFill>
+        <p:spPr>
+          <a:xfrm>
+            <a:off x="457200" y="1600200"/>
+            <a:ext cx="7801332" cy="5029200"/>
+          </a:xfrm>
+          <a:prstGeom prst="rect">
+            <a:avLst/>
+          </a:prstGeom>
+        </p:spPr>
+      </p:pic>
+      <p:sp>
+        <p:nvSpPr>
+          <p:cNvPr id="5" name="TextBox 4"/>
+          <p:cNvSpPr txBox="1"/>
+          <p:nvPr/>
+        </p:nvSpPr>
+        <p:spPr>
+          <a:xfrm>
+            <a:off x="8412480" y="2011680"/>
+            <a:ext cx="3474720" cy="4572000"/>
+          </a:xfrm>
+          <a:prstGeom prst="rect">
+            <a:avLst/>
+          </a:prstGeom>
+          <a:noFill/>
+        </p:spPr>
+        <p:txBody>
+          <a:bodyPr wrap="square">
+            <a:spAutoFit/>
+          </a:bodyPr>
+          <a:lstStyle/>
+          <a:p>
+            <a:pPr>
+              <a:spcAft>
+                <a:spcPts val="600"/>
+              </a:spcAft>
+              <a:defRPr sz="2000" b="0">
+                <a:solidFill>
+                  <a:srgbClr val="444444"/>
+                </a:solidFill>
+              </a:defRPr>
+            </a:pPr>
+            <a:r>
+              <a:t>All C(6,3) = 20 baskets on the risk/return plane.</a:t>
+            </a:r>
+          </a:p>
+          <a:p>
+            <a:pPr>
+              <a:spcAft>
+                <a:spcPts val="600"/>
+              </a:spcAft>
+              <a:defRPr sz="2000" b="0">
+                <a:solidFill>
+                  <a:srgbClr val="444444"/>
+                </a:solidFill>
+              </a:defRPr>
+            </a:pPr>
+            <a:r>
+              <a:t>Basket count grows as C(n,k): ~185 000 for 10-of-20.</a:t>
+            </a:r>
+          </a:p>
+          <a:p>
+            <a:pPr>
+              <a:spcAft>
+                <a:spcPts val="600"/>
+              </a:spcAft>
+              <a:defRPr sz="2000" b="0">
+                <a:solidFill>
+                  <a:srgbClr val="444444"/>
+                </a:solidFill>
+              </a:defRPr>
+            </a:pPr>
+            <a:r>
+              <a:t>Goal: find the best basket for a client's risk aversion q.</a:t>
+            </a:r>
+          </a:p>
+        </p:txBody>
+      </p:sp>
+      <p:sp>
+        <p:nvSpPr>
+          <p:cNvPr id="6" name="TextBox 5"/>
+          <p:cNvSpPr txBox="1"/>
+          <p:nvPr/>
+        </p:nvSpPr>
+        <p:spPr>
+          <a:xfrm>
+            <a:off x="8412480" y="5669280"/>
+            <a:ext cx="3566160" cy="914400"/>
+          </a:xfrm>
+          <a:prstGeom prst="rect">
+            <a:avLst/>
+          </a:prstGeom>
+          <a:noFill/>
+        </p:spPr>
+        <p:txBody>
+          <a:bodyPr wrap="square">
+            <a:spAutoFit/>
+          </a:bodyPr>
+          <a:lstStyle/>
+          <a:p>
+            <a:pPr>
+              <a:spcAft>
+                <a:spcPts val="600"/>
+              </a:spcAft>
+              <a:defRPr sz="2000" b="0">
+                <a:solidFill>
+                  <a:srgbClr val="3B1F7A"/>
+                </a:solidFill>
+              </a:defRPr>
+            </a:pPr>
+            <a:r>
+              <a:t>Akella Ahlad Achintya</a:t>
+            </a:r>
+          </a:p>
+          <a:p>
+            <a:pPr>
+              <a:spcAft>
+                <a:spcPts val="600"/>
+              </a:spcAft>
+              <a:defRPr sz="2000" b="0">
+                <a:solidFill>
+                  <a:srgbClr val="3B1F7A"/>
+                </a:solidFill>
+              </a:defRPr>
+            </a:pPr>
+            <a:r>
+              <a:t>Qiskit Fall Fest 2026 · Track I2</a:t>
+            </a:r>
+          </a:p>
+        </p:txBody>
+      </p:sp>
+    </p:spTree>
+  </p:cSld>
+  <p:clrMapOvr>
+    <a:masterClrMapping/>
+  </p:clrMapOvr>
+</p:sld>
+</file>
+
+<file path=ppt/slides/slide3.xml><?xml version="1.0" encoding="utf-8"?>
+<p:sld xmlns:a="http://schemas.openxmlformats.org/drawingml/2006/main" xmlns:p="http://schemas.openxmlformats.org/presentationml/2006/main" xmlns:r="http://schemas.openxmlformats.org/officeDocument/2006/relationships">
+  <p:cSld>
+    <p:spTree>
+      <p:nvGrpSpPr>
+        <p:cNvPr id="1" name=""/>
+        <p:cNvGrpSpPr/>
+        <p:nvPr/>
+      </p:nvGrpSpPr>
+      <p:grpSpPr/>
+      <p:sp>
+        <p:nvSpPr>
+          <p:cNvPr id="2" name="TextBox 1"/>
+          <p:cNvSpPr txBox="1"/>
+          <p:nvPr/>
+        </p:nvSpPr>
+        <p:spPr>
+          <a:xfrm>
+            <a:off x="457200" y="274320"/>
+            <a:ext cx="11247120" cy="822960"/>
+          </a:xfrm>
+          <a:prstGeom prst="rect">
+            <a:avLst/>
+          </a:prstGeom>
+          <a:noFill/>
+        </p:spPr>
+        <p:txBody>
+          <a:bodyPr wrap="square">
+            <a:spAutoFit/>
+          </a:bodyPr>
+          <a:lstStyle/>
+          <a:p>
+            <a:pPr>
+              <a:spcAft>
+                <a:spcPts val="600"/>
+              </a:spcAft>
+              <a:defRPr sz="3400" b="1">
+                <a:solidFill>
+                  <a:srgbClr val="3B1F7A"/>
+                </a:solidFill>
+              </a:defRPr>
+            </a:pPr>
+            <a:r>
               <a:t>Put the constraint in the circuit, not in the cost</a:t>
             </a:r>
           </a:p>
@@ -4284,7 +4502,7 @@
 </p:sld>
 </file>
 
-<file path=ppt/slides/slide3.xml><?xml version="1.0" encoding="utf-8"?>
+<file path=ppt/slides/slide4.xml><?xml version="1.0" encoding="utf-8"?>
 <p:sld xmlns:a="http://schemas.openxmlformats.org/drawingml/2006/main" xmlns:p="http://schemas.openxmlformats.org/presentationml/2006/main" xmlns:r="http://schemas.openxmlformats.org/officeDocument/2006/relationships">
   <p:cSld>
     <p:spTree>

</xml_diff>

<commit_message>
docs(slides): final speaker notes for all four slides
Co-Authored-By: Claude Opus 5.5 <noreply@anthropic.com>
</commit_message>
<xml_diff>
--- a/docs/slides.pptx
+++ b/docs/slides.pptx
@@ -505,7 +505,7 @@
           <a:lstStyle/>
           <a:p>
             <a:r>
-              <a:t>Standard QAOA treats 'pick exactly k stocks' as a penalty and ends up no better than random guessing, so I built the constraint into the circuit: every shot is a valid portfolio, it finds the optimal basket about 7× more often than chance, and the same symmetry lets me throw out hardware errors for free on a real IBM quantum computer.</a:t>
+              <a:t>Hi, I'm Akella Ahlad Achintya. My project is Q-Folio: using QAOA on Qiskit to pick the best stock basket — and I ran it on a real IBM quantum computer. One line: standard QAOA treats 'pick exactly k stocks' as a penalty and ends up no better than chance; I built that rule into the circuit, so every answer is a valid portfolio.</a:t>
             </a:r>
           </a:p>
         </p:txBody>
@@ -575,7 +575,7 @@
           <a:lstStyle/>
           <a:p>
             <a:r>
-              <a:t>Hi, I'm Akella Ahlad Achintya. Robo-advisors in India sell model baskets: a few stocks, equal weights, for a given risk profile. Choosing which k stocks go in is a combinatorial problem. Here I pick 3 of 6 NSE large caps, which is 20 possible baskets; each dot on this chart is one of them. We want return up and risk down, and the client's risk aversion q sets the trade-off. The blue star is the best basket for q = 0.5, and the orange diamond is a very close runner-up. At 20 baskets a laptop checks them all instantly, but the count explodes as C(n,k), so it is a natural test bed for quantum optimisation.</a:t>
+              <a:t>Robo-advisors sell model baskets — say, the best 3 out of 6 stocks. 'Best' means high return and low risk. Each dot on this chart is one possible basket; there are 20 here. That's easy, but the number of baskets explodes as you add stocks — that's why it's a hard optimisation problem. I used real NSE prices from 2023 to 2025. Each stock is one qubit: 1 means hold it, 0 means don't. Two knobs: k is the basket size, and q is risk aversion — higher q means a more conservative client.</a:t>
             </a:r>
           </a:p>
         </p:txBody>
@@ -645,7 +645,7 @@
           <a:lstStyle/>
           <a:p>
             <a:r>
-              <a:t>The textbook way to say 'exactly 3 stocks' is a penalty term in the cost. I tested it carefully: only 75% of its samples are valid baskets, and it finds the best one 4% of the time, the same as random guessing at 5%. So I moved the constraint into the circuit. A Dicke state starts in an equal mix of only the valid baskets, and an XY mixer swaps stocks in and out without changing the count. Every shot is a real portfolio. Over 24 test instances the best basket comes up 34% of the time, about the same as simulated annealing at 36%. Grey bars are classical baselines, blue is ours, orange is the penalty approach.</a:t>
+              <a:t>The textbook way adds a penalty for picking the wrong number of stocks. It searches all 64 combinations, 44 of which are invalid — and I found it does no better than random guessing. So I changed the circuit. A Dicke state starts in an equal mix of only the valid baskets, and an XY mixer swaps one stock in and one out, so the count never changes. Result: 100% of answers are valid baskets, and the best basket shows up 34% of the time versus 5% for random — about seven times better, and comparable to simulated annealing. Tested on 25 different instances.</a:t>
             </a:r>
           </a:p>
         </p:txBody>
@@ -715,7 +715,7 @@
           <a:lstStyle/>
           <a:p>
             <a:r>
-              <a:t>Then I ran the same circuit on IBM's ibm_kingston, with 4 stocks and 2 picked. On the left is the raw output from the IBM dashboard: the tallest bar is the optimal basket and the second is the runner-up. Noise lets some invalid baskets through, about 22% of shots. The ideal circuit can never produce them, so I simply throw them away. That is free error detection. The optimal basket goes from 51% to 65%, against 17% for a random guess. Honest limits: at this size a laptop solves it instantly, so I claim no quantum advantage. The point is that building business constraints into the circuit is what makes quantum optimisation work at all. Code and live demo are behind the QR codes. Thank you, I'm Akella Ahlad Achintya.</a:t>
+              <a:t>Then I ran it on IBM's ibm_kingston quantum computer. This histogram is straight from IBM's dashboard: the tallest bar, 1001, is the optimal basket — Reliance plus ITC — and the second is the runner-up. Noise lets some invalid answers through, but my circuit can never produce those, so I can safely throw them away. That took us from 51% to 65% correct, versus 17% for random. To be honest about limits: at this size a laptop solves it instantly with brute force, so I'm not claiming quantum advantage. The contribution is showing that building constraints into the circuit is what makes quantum optimisation work — and it even gives free error detection on hardware. The code, live demo and report are at these QR codes. Thank you.</a:t>
             </a:r>
           </a:p>
         </p:txBody>

</xml_diff>